<commit_message>
Desenho unico, meta de funding US$ 100 mil/ano, retencao de 30 dias e SOW da PoC
- Desenho 2 descartado: diagrama v4.4 com 5 abas, docs, ADR-003, listas e deck atualizados
- POC do funding no Desenho 1; S3 de entrada e saida retem 30 dias
- Calculo de consumo com meta de US$ 100 mil/ano (E2 ~ US$ 10,7 mil/mes)
- SOW da PoC em EN (sow/), diagrama e pos-processo da equipe, revisado pelo especialista

Co-Authored-By: Claude Sonnet 5.5 <noreply@anthropic.com>
</commit_message>
<xml_diff>
--- a/deck/saida/3Coracoes_Arquitetura_Recomendacao_SKU_v1.pptx
+++ b/deck/saida/3Coracoes_Arquitetura_Recomendacao_SKU_v1.pptx
@@ -1336,7 +1336,7 @@
               <a:rPr lang="en-US" dirty="0"/>
               <a:t>Mensagem: quatro passos levam do alinhamento à primeira rodada com teste A/B.
 Pontos a confirmar: datas, responsáveis e contatos.
-[Sources] Arquitetura proposta v4, aba 6.</a:t>
+[Sources] Arquitetura proposta v4, aba 4.</a:t>
             </a:r>
             <a:endParaRPr lang="en-US" dirty="0"/>
           </a:p>
@@ -25500,7 +25500,7 @@
                 <a:ea typeface="Lato Black" pitchFamily="34" charset="-122"/>
                 <a:cs typeface="Lato Black" pitchFamily="34" charset="-120"/>
               </a:rPr>
-              <a:t>Controle na AWS</a:t>
+              <a:t>Piso em SQL</a:t>
             </a:r>
             <a:endParaRPr lang="en-US" sz="2400" dirty="0"/>
           </a:p>
@@ -25539,7 +25539,7 @@
                 <a:ea typeface="Lato" pitchFamily="34" charset="-122"/>
                 <a:cs typeface="Lato" pitchFamily="34" charset="-120"/>
               </a:rPr>
-              <a:t>Desenho 2: sorteio, medição e painel também na AWS</a:t>
+              <a:t>regras de cesta e popularidade no Snowflake, se o Personalize não confirmar a cesta</a:t>
             </a:r>
             <a:endParaRPr lang="en-US" sz="1200" dirty="0"/>
           </a:p>
@@ -42615,7 +42615,7 @@
                 <a:ea typeface="Lato" pitchFamily="34" charset="-122"/>
                 <a:cs typeface="Lato" pitchFamily="34" charset="-120"/>
               </a:rPr>
-              <a:t>Detalhe na aba 5 do diagrama de arquitetura</a:t>
+              <a:t>Detalhe na aba 3 do diagrama de arquitetura</a:t>
             </a:r>
             <a:endParaRPr lang="en-US" sz="1013" dirty="0"/>
           </a:p>

</xml_diff>